<commit_message>
docs: fix proposal material to match actual implementation (v78)
- Slide 5: rich menu mockup from 2x3 (6 buttons) to actual 3-button layout (予約する / 予約確認 / お問い合わせ)
- Slide 7: dashboard cards to match implementation (本日の予約 / 本日の売上 / 今月の売上 / コース残少). Backup note updated to 毎週日曜 午前2時
- Slide 9: specify CSV output for 売上明細・顧客一覧・予約台帳. Removed CSV bulk import claim
- Slide 11: backup schedule 5時 → 午前2時, retention 過去30日 → 過去4週間
- Slide 12: security wording trimmed — '全操作ログ記録' replaced with '管理者ログイン履歴/LINEメッセージ送受信履歴の自動記録'
- Slide 17: FAQ Q3 reworded (removed '一括でインポート'); PPTX FAQ Q2 残存していた 'スプレッドシート' を 'Googleドライブ' に修正

Regenerated pptx and pdf both 20 slides.
</commit_message>
<xml_diff>
--- a/docs/SALON_PROPOSAL.pptx
+++ b/docs/SALON_PROPOSAL.pptx
@@ -6803,7 +6803,7 @@
                 <a:latin typeface="メイリオ"/>
                 <a:ea typeface="メイリオ"/>
               </a:rPr>
-              <a:t>毎週日曜5時、自動でデータを保管</a:t>
+              <a:t>毎週日曜 午前2時、自動でデータを保管</a:t>
             </a:r>
           </a:p>
         </p:txBody>
@@ -6927,7 +6927,7 @@
                 <a:latin typeface="メイリオ"/>
                 <a:ea typeface="メイリオ"/>
               </a:rPr>
-              <a:t>5:00</a:t>
+              <a:t>2:00</a:t>
             </a:r>
           </a:p>
         </p:txBody>
@@ -7557,7 +7557,7 @@
                 <a:latin typeface="メイリオ"/>
                 <a:ea typeface="メイリオ"/>
               </a:rPr>
-              <a:t>✓ 2026/04/19 05:00 バックアップ完了</a:t>
+              <a:t>✓ 2026/04/19 02:00 バックアップ完了</a:t>
             </a:r>
           </a:p>
         </p:txBody>
@@ -7658,7 +7658,7 @@
                 <a:latin typeface="メイリオ"/>
                 <a:ea typeface="メイリオ"/>
               </a:rPr>
-              <a:t>いつでも過去30日分から復元可能</a:t>
+              <a:t>過去4週間分を自動保管</a:t>
             </a:r>
           </a:p>
         </p:txBody>
@@ -8270,6 +8270,23 @@
                 <a:latin typeface="メイリオ"/>
                 <a:ea typeface="メイリオ"/>
               </a:rPr>
+              <a:t>SHA-256で不可逆変換して保存。</a:t>
+            </a:r>
+          </a:p>
+          <a:p>
+            <a:pPr algn="l">
+              <a:lnSpc>
+                <a:spcPct val="130000"/>
+              </a:lnSpc>
+            </a:pPr>
+            <a:r>
+              <a:rPr sz="1100" b="0">
+                <a:solidFill>
+                  <a:srgbClr val="333333"/>
+                </a:solidFill>
+                <a:latin typeface="メイリオ"/>
+                <a:ea typeface="メイリオ"/>
+              </a:rPr>
               <a:t>万一データが見られても</a:t>
             </a:r>
           </a:p>
@@ -8287,24 +8304,7 @@
                 <a:latin typeface="メイリオ"/>
                 <a:ea typeface="メイリオ"/>
               </a:rPr>
-              <a:t>パスワードは復元不可能な</a:t>
-            </a:r>
-          </a:p>
-          <a:p>
-            <a:pPr algn="l">
-              <a:lnSpc>
-                <a:spcPct val="130000"/>
-              </a:lnSpc>
-            </a:pPr>
-            <a:r>
-              <a:rPr sz="1100" b="0">
-                <a:solidFill>
-                  <a:srgbClr val="333333"/>
-                </a:solidFill>
-                <a:latin typeface="メイリオ"/>
-                <a:ea typeface="メイリオ"/>
-              </a:rPr>
-              <a:t>形で保管されます。</a:t>
+              <a:t>パスワードは復元不可能です。</a:t>
             </a:r>
           </a:p>
         </p:txBody>
@@ -8473,7 +8473,7 @@
                 <a:latin typeface="メイリオ"/>
                 <a:ea typeface="メイリオ"/>
               </a:rPr>
-              <a:t>通信は暗号化</a:t>
+              <a:t>通信はすべて暗号化</a:t>
             </a:r>
           </a:p>
         </p:txBody>
@@ -8530,7 +8530,7 @@
                 <a:latin typeface="メイリオ"/>
                 <a:ea typeface="メイリオ"/>
               </a:rPr>
-              <a:t>すべての通信を暗号化。</a:t>
+              <a:t>通信はHTTPSで暗号化。</a:t>
             </a:r>
           </a:p>
           <a:p>
@@ -8547,7 +8547,7 @@
                 <a:latin typeface="メイリオ"/>
                 <a:ea typeface="メイリオ"/>
               </a:rPr>
-              <a:t>盗聴される心配はありません。</a:t>
+              <a:t>盗聴の心配はありません。</a:t>
             </a:r>
           </a:p>
         </p:txBody>
@@ -8756,7 +8756,7 @@
                 <a:latin typeface="メイリオ"/>
                 <a:ea typeface="メイリオ"/>
               </a:rPr>
-              <a:t>ログイン情報は保存せず、</a:t>
+              <a:t>ログイン情報の保存を選べる方式。</a:t>
             </a:r>
           </a:p>
           <a:p>
@@ -8773,7 +8773,7 @@
                 <a:latin typeface="メイリオ"/>
                 <a:ea typeface="メイリオ"/>
               </a:rPr>
-              <a:t>ブラウザを閉じれば自動ログアウト。</a:t>
+              <a:t>OFFならブラウザを閉じた時点で</a:t>
             </a:r>
           </a:p>
           <a:p>
@@ -8790,7 +8790,7 @@
                 <a:latin typeface="メイリオ"/>
                 <a:ea typeface="メイリオ"/>
               </a:rPr>
-              <a:t>店舗の共用PCでも使えます。</a:t>
+              <a:t>自動ログアウトします。</a:t>
             </a:r>
           </a:p>
         </p:txBody>
@@ -8959,7 +8959,7 @@
                 <a:latin typeface="メイリオ"/>
                 <a:ea typeface="メイリオ"/>
               </a:rPr>
-              <a:t>全操作ログ記録</a:t>
+              <a:t>操作履歴を自動記録</a:t>
             </a:r>
           </a:p>
         </p:txBody>
@@ -8999,7 +8999,7 @@
                 <a:latin typeface="メイリオ"/>
                 <a:ea typeface="メイリオ"/>
               </a:rPr>
-              <a:t>「誰がいつ何をしたか」を</a:t>
+              <a:t>管理者ログイン履歴と</a:t>
             </a:r>
           </a:p>
           <a:p>
@@ -9016,7 +9016,7 @@
                 <a:latin typeface="メイリオ"/>
                 <a:ea typeface="メイリオ"/>
               </a:rPr>
-              <a:t>自動で記録。</a:t>
+              <a:t>LINEメッセージ送受信履歴を</a:t>
             </a:r>
           </a:p>
           <a:p>
@@ -9033,7 +9033,7 @@
                 <a:latin typeface="メイリオ"/>
                 <a:ea typeface="メイリオ"/>
               </a:rPr>
-              <a:t>トラブル時の追跡が可能です。</a:t>
+              <a:t>自動記録。後から確認できます。</a:t>
             </a:r>
           </a:p>
         </p:txBody>
@@ -15664,7 +15664,7 @@
                 <a:latin typeface="メイリオ"/>
                 <a:ea typeface="メイリオ"/>
               </a:rPr>
-              <a:t>エクセル・CSVで書き出せる形式であれば、一括でインポートできます。移行作業は弊社で代行しますのでご安心ください。</a:t>
+              <a:t>現時点では売上明細・顧客一覧・予約台帳のCSV出力に対応しています。他システムからのデータ移行は個別にご相談のうえ対応いたします。</a:t>
             </a:r>
           </a:p>
         </p:txBody>
@@ -23352,14 +23352,54 @@
       </p:sp>
       <p:sp>
         <p:nvSpPr>
-          <p:cNvPr id="13" name="Rounded Rectangle 12"/>
+          <p:cNvPr id="13" name="TextBox 12"/>
+          <p:cNvSpPr txBox="1"/>
+          <p:nvPr/>
+        </p:nvSpPr>
+        <p:spPr>
+          <a:xfrm>
+            <a:off x="640080" y="2423160"/>
+            <a:ext cx="3017520" cy="365760"/>
+          </a:xfrm>
+          <a:prstGeom prst="rect">
+            <a:avLst/>
+          </a:prstGeom>
+          <a:noFill/>
+        </p:spPr>
+        <p:txBody>
+          <a:bodyPr wrap="square" lIns="36000" rIns="36000" tIns="18000" bIns="18000" anchor="t">
+            <a:spAutoFit/>
+          </a:bodyPr>
+          <a:lstStyle/>
+          <a:p>
+            <a:pPr algn="ctr">
+              <a:lnSpc>
+                <a:spcPct val="120000"/>
+              </a:lnSpc>
+            </a:pPr>
+            <a:r>
+              <a:rPr sz="900" b="0">
+                <a:solidFill>
+                  <a:srgbClr val="888888"/>
+                </a:solidFill>
+                <a:latin typeface="メイリオ"/>
+                <a:ea typeface="メイリオ"/>
+              </a:rPr>
+              <a:t>リッチメニュー</a:t>
+            </a:r>
+          </a:p>
+        </p:txBody>
+      </p:sp>
+      <p:sp>
+        <p:nvSpPr>
+          <p:cNvPr id="14" name="Rounded Rectangle 13"/>
           <p:cNvSpPr/>
           <p:nvPr/>
         </p:nvSpPr>
         <p:spPr>
           <a:xfrm>
-            <a:off x="777240" y="2971800"/>
-            <a:ext cx="777240" cy="731520"/>
+            <a:off x="777240" y="3657600"/>
+            <a:ext cx="1188720" cy="868680"/>
           </a:xfrm>
           <a:prstGeom prst="roundRect">
             <a:avLst/>
@@ -23396,14 +23436,14 @@
       </p:sp>
       <p:sp>
         <p:nvSpPr>
-          <p:cNvPr id="14" name="TextBox 13"/>
-          <p:cNvSpPr txBox="1"/>
-          <p:nvPr/>
-        </p:nvSpPr>
-        <p:spPr>
-          <a:xfrm>
-            <a:off x="777240" y="2971800"/>
-            <a:ext cx="777240" cy="731520"/>
+          <p:cNvPr id="15" name="TextBox 14"/>
+          <p:cNvSpPr txBox="1"/>
+          <p:nvPr/>
+        </p:nvSpPr>
+        <p:spPr>
+          <a:xfrm>
+            <a:off x="777240" y="3657600"/>
+            <a:ext cx="1188720" cy="868680"/>
           </a:xfrm>
           <a:prstGeom prst="rect">
             <a:avLst/>
@@ -23422,28 +23462,28 @@
               </a:lnSpc>
             </a:pPr>
             <a:r>
-              <a:rPr sz="1000" b="1">
+              <a:rPr sz="1100" b="1">
                 <a:solidFill>
                   <a:srgbClr val="FFFFFF"/>
                 </a:solidFill>
                 <a:latin typeface="メイリオ"/>
                 <a:ea typeface="メイリオ"/>
               </a:rPr>
-              <a:t>予約</a:t>
-            </a:r>
-          </a:p>
-        </p:txBody>
-      </p:sp>
-      <p:sp>
-        <p:nvSpPr>
-          <p:cNvPr id="15" name="Rounded Rectangle 14"/>
+              <a:t>予約する</a:t>
+            </a:r>
+          </a:p>
+        </p:txBody>
+      </p:sp>
+      <p:sp>
+        <p:nvSpPr>
+          <p:cNvPr id="16" name="Rounded Rectangle 15"/>
           <p:cNvSpPr/>
           <p:nvPr/>
         </p:nvSpPr>
         <p:spPr>
           <a:xfrm>
-            <a:off x="1600200" y="2971800"/>
-            <a:ext cx="777240" cy="731520"/>
+            <a:off x="2057400" y="3657600"/>
+            <a:ext cx="1188720" cy="868680"/>
           </a:xfrm>
           <a:prstGeom prst="roundRect">
             <a:avLst/>
@@ -23480,14 +23520,14 @@
       </p:sp>
       <p:sp>
         <p:nvSpPr>
-          <p:cNvPr id="16" name="TextBox 15"/>
-          <p:cNvSpPr txBox="1"/>
-          <p:nvPr/>
-        </p:nvSpPr>
-        <p:spPr>
-          <a:xfrm>
-            <a:off x="1600200" y="2971800"/>
-            <a:ext cx="777240" cy="731520"/>
+          <p:cNvPr id="17" name="TextBox 16"/>
+          <p:cNvSpPr txBox="1"/>
+          <p:nvPr/>
+        </p:nvSpPr>
+        <p:spPr>
+          <a:xfrm>
+            <a:off x="2057400" y="3657600"/>
+            <a:ext cx="1188720" cy="868680"/>
           </a:xfrm>
           <a:prstGeom prst="rect">
             <a:avLst/>
@@ -23506,28 +23546,28 @@
               </a:lnSpc>
             </a:pPr>
             <a:r>
-              <a:rPr sz="1000" b="1">
+              <a:rPr sz="1100" b="1">
                 <a:solidFill>
                   <a:srgbClr val="FFFFFF"/>
                 </a:solidFill>
                 <a:latin typeface="メイリオ"/>
                 <a:ea typeface="メイリオ"/>
               </a:rPr>
-              <a:t>変更</a:t>
-            </a:r>
-          </a:p>
-        </p:txBody>
-      </p:sp>
-      <p:sp>
-        <p:nvSpPr>
-          <p:cNvPr id="17" name="Rounded Rectangle 16"/>
+              <a:t>予約確認</a:t>
+            </a:r>
+          </a:p>
+        </p:txBody>
+      </p:sp>
+      <p:sp>
+        <p:nvSpPr>
+          <p:cNvPr id="18" name="Rounded Rectangle 17"/>
           <p:cNvSpPr/>
           <p:nvPr/>
         </p:nvSpPr>
         <p:spPr>
           <a:xfrm>
-            <a:off x="2423160" y="2971800"/>
-            <a:ext cx="777240" cy="731520"/>
+            <a:off x="777240" y="4617720"/>
+            <a:ext cx="2468880" cy="868680"/>
           </a:xfrm>
           <a:prstGeom prst="roundRect">
             <a:avLst/>
@@ -23564,14 +23604,14 @@
       </p:sp>
       <p:sp>
         <p:nvSpPr>
-          <p:cNvPr id="18" name="TextBox 17"/>
-          <p:cNvSpPr txBox="1"/>
-          <p:nvPr/>
-        </p:nvSpPr>
-        <p:spPr>
-          <a:xfrm>
-            <a:off x="2423160" y="2971800"/>
-            <a:ext cx="777240" cy="731520"/>
+          <p:cNvPr id="19" name="TextBox 18"/>
+          <p:cNvSpPr txBox="1"/>
+          <p:nvPr/>
+        </p:nvSpPr>
+        <p:spPr>
+          <a:xfrm>
+            <a:off x="777240" y="4617720"/>
+            <a:ext cx="2468880" cy="868680"/>
           </a:xfrm>
           <a:prstGeom prst="rect">
             <a:avLst/>
@@ -23590,313 +23630,21 @@
               </a:lnSpc>
             </a:pPr>
             <a:r>
-              <a:rPr sz="1000" b="1">
+              <a:rPr sz="1200" b="1">
                 <a:solidFill>
                   <a:srgbClr val="FFFFFF"/>
                 </a:solidFill>
                 <a:latin typeface="メイリオ"/>
                 <a:ea typeface="メイリオ"/>
               </a:rPr>
-              <a:t>キャンセル</a:t>
-            </a:r>
-          </a:p>
-        </p:txBody>
-      </p:sp>
-      <p:sp>
-        <p:nvSpPr>
-          <p:cNvPr id="19" name="Rounded Rectangle 18"/>
-          <p:cNvSpPr/>
-          <p:nvPr/>
-        </p:nvSpPr>
-        <p:spPr>
-          <a:xfrm>
-            <a:off x="777240" y="3749040"/>
-            <a:ext cx="777240" cy="731520"/>
-          </a:xfrm>
-          <a:prstGeom prst="roundRect">
-            <a:avLst/>
-          </a:prstGeom>
-          <a:solidFill>
-            <a:srgbClr val="D4688A"/>
-          </a:solidFill>
-          <a:ln>
-            <a:noFill/>
-          </a:ln>
-          <a:effectLst/>
-        </p:spPr>
-        <p:style>
-          <a:lnRef idx="1">
-            <a:schemeClr val="accent1"/>
-          </a:lnRef>
-          <a:fillRef idx="3">
-            <a:schemeClr val="accent1"/>
-          </a:fillRef>
-          <a:effectRef idx="2">
-            <a:schemeClr val="accent1"/>
-          </a:effectRef>
-          <a:fontRef idx="minor">
-            <a:schemeClr val="lt1"/>
-          </a:fontRef>
-        </p:style>
-        <p:txBody>
-          <a:bodyPr rtlCol="0" anchor="ctr"/>
-          <a:lstStyle/>
-          <a:p>
-            <a:pPr algn="ctr"/>
-          </a:p>
-        </p:txBody>
-      </p:sp>
-      <p:sp>
-        <p:nvSpPr>
-          <p:cNvPr id="20" name="TextBox 19"/>
-          <p:cNvSpPr txBox="1"/>
-          <p:nvPr/>
-        </p:nvSpPr>
-        <p:spPr>
-          <a:xfrm>
-            <a:off x="777240" y="3749040"/>
-            <a:ext cx="777240" cy="731520"/>
-          </a:xfrm>
-          <a:prstGeom prst="rect">
-            <a:avLst/>
-          </a:prstGeom>
-          <a:noFill/>
-        </p:spPr>
-        <p:txBody>
-          <a:bodyPr wrap="square" lIns="36000" rIns="36000" tIns="18000" bIns="18000" anchor="ctr">
-            <a:spAutoFit/>
-          </a:bodyPr>
-          <a:lstStyle/>
-          <a:p>
-            <a:pPr algn="ctr">
-              <a:lnSpc>
-                <a:spcPct val="120000"/>
-              </a:lnSpc>
-            </a:pPr>
-            <a:r>
-              <a:rPr sz="1000" b="1">
-                <a:solidFill>
-                  <a:srgbClr val="FFFFFF"/>
-                </a:solidFill>
-                <a:latin typeface="メイリオ"/>
-                <a:ea typeface="メイリオ"/>
-              </a:rPr>
-              <a:t>残回数</a:t>
-            </a:r>
-          </a:p>
-        </p:txBody>
-      </p:sp>
-      <p:sp>
-        <p:nvSpPr>
-          <p:cNvPr id="21" name="Rounded Rectangle 20"/>
-          <p:cNvSpPr/>
-          <p:nvPr/>
-        </p:nvSpPr>
-        <p:spPr>
-          <a:xfrm>
-            <a:off x="1600200" y="3749040"/>
-            <a:ext cx="777240" cy="731520"/>
-          </a:xfrm>
-          <a:prstGeom prst="roundRect">
-            <a:avLst/>
-          </a:prstGeom>
-          <a:solidFill>
-            <a:srgbClr val="D4A574"/>
-          </a:solidFill>
-          <a:ln>
-            <a:noFill/>
-          </a:ln>
-          <a:effectLst/>
-        </p:spPr>
-        <p:style>
-          <a:lnRef idx="1">
-            <a:schemeClr val="accent1"/>
-          </a:lnRef>
-          <a:fillRef idx="3">
-            <a:schemeClr val="accent1"/>
-          </a:fillRef>
-          <a:effectRef idx="2">
-            <a:schemeClr val="accent1"/>
-          </a:effectRef>
-          <a:fontRef idx="minor">
-            <a:schemeClr val="lt1"/>
-          </a:fontRef>
-        </p:style>
-        <p:txBody>
-          <a:bodyPr rtlCol="0" anchor="ctr"/>
-          <a:lstStyle/>
-          <a:p>
-            <a:pPr algn="ctr"/>
-          </a:p>
-        </p:txBody>
-      </p:sp>
-      <p:sp>
-        <p:nvSpPr>
-          <p:cNvPr id="22" name="TextBox 21"/>
-          <p:cNvSpPr txBox="1"/>
-          <p:nvPr/>
-        </p:nvSpPr>
-        <p:spPr>
-          <a:xfrm>
-            <a:off x="1600200" y="3749040"/>
-            <a:ext cx="777240" cy="731520"/>
-          </a:xfrm>
-          <a:prstGeom prst="rect">
-            <a:avLst/>
-          </a:prstGeom>
-          <a:noFill/>
-        </p:spPr>
-        <p:txBody>
-          <a:bodyPr wrap="square" lIns="36000" rIns="36000" tIns="18000" bIns="18000" anchor="ctr">
-            <a:spAutoFit/>
-          </a:bodyPr>
-          <a:lstStyle/>
-          <a:p>
-            <a:pPr algn="ctr">
-              <a:lnSpc>
-                <a:spcPct val="120000"/>
-              </a:lnSpc>
-            </a:pPr>
-            <a:r>
-              <a:rPr sz="1000" b="1">
-                <a:solidFill>
-                  <a:srgbClr val="FFFFFF"/>
-                </a:solidFill>
-                <a:latin typeface="メイリオ"/>
-                <a:ea typeface="メイリオ"/>
-              </a:rPr>
-              <a:t>営業日</a:t>
-            </a:r>
-          </a:p>
-        </p:txBody>
-      </p:sp>
-      <p:sp>
-        <p:nvSpPr>
-          <p:cNvPr id="23" name="Rounded Rectangle 22"/>
-          <p:cNvSpPr/>
-          <p:nvPr/>
-        </p:nvSpPr>
-        <p:spPr>
-          <a:xfrm>
-            <a:off x="2423160" y="3749040"/>
-            <a:ext cx="777240" cy="731520"/>
-          </a:xfrm>
-          <a:prstGeom prst="roundRect">
-            <a:avLst/>
-          </a:prstGeom>
-          <a:solidFill>
-            <a:srgbClr val="7B4A5C"/>
-          </a:solidFill>
-          <a:ln>
-            <a:noFill/>
-          </a:ln>
-          <a:effectLst/>
-        </p:spPr>
-        <p:style>
-          <a:lnRef idx="1">
-            <a:schemeClr val="accent1"/>
-          </a:lnRef>
-          <a:fillRef idx="3">
-            <a:schemeClr val="accent1"/>
-          </a:fillRef>
-          <a:effectRef idx="2">
-            <a:schemeClr val="accent1"/>
-          </a:effectRef>
-          <a:fontRef idx="minor">
-            <a:schemeClr val="lt1"/>
-          </a:fontRef>
-        </p:style>
-        <p:txBody>
-          <a:bodyPr rtlCol="0" anchor="ctr"/>
-          <a:lstStyle/>
-          <a:p>
-            <a:pPr algn="ctr"/>
-          </a:p>
-        </p:txBody>
-      </p:sp>
-      <p:sp>
-        <p:nvSpPr>
-          <p:cNvPr id="24" name="TextBox 23"/>
-          <p:cNvSpPr txBox="1"/>
-          <p:nvPr/>
-        </p:nvSpPr>
-        <p:spPr>
-          <a:xfrm>
-            <a:off x="2423160" y="3749040"/>
-            <a:ext cx="777240" cy="731520"/>
-          </a:xfrm>
-          <a:prstGeom prst="rect">
-            <a:avLst/>
-          </a:prstGeom>
-          <a:noFill/>
-        </p:spPr>
-        <p:txBody>
-          <a:bodyPr wrap="square" lIns="36000" rIns="36000" tIns="18000" bIns="18000" anchor="ctr">
-            <a:spAutoFit/>
-          </a:bodyPr>
-          <a:lstStyle/>
-          <a:p>
-            <a:pPr algn="ctr">
-              <a:lnSpc>
-                <a:spcPct val="120000"/>
-              </a:lnSpc>
-            </a:pPr>
-            <a:r>
-              <a:rPr sz="1000" b="1">
-                <a:solidFill>
-                  <a:srgbClr val="FFFFFF"/>
-                </a:solidFill>
-                <a:latin typeface="メイリオ"/>
-                <a:ea typeface="メイリオ"/>
-              </a:rPr>
-              <a:t>お問合せ</a:t>
-            </a:r>
-          </a:p>
-        </p:txBody>
-      </p:sp>
-      <p:sp>
-        <p:nvSpPr>
-          <p:cNvPr id="25" name="TextBox 24"/>
-          <p:cNvSpPr txBox="1"/>
-          <p:nvPr/>
-        </p:nvSpPr>
-        <p:spPr>
-          <a:xfrm>
-            <a:off x="640080" y="2423160"/>
-            <a:ext cx="3017520" cy="365760"/>
-          </a:xfrm>
-          <a:prstGeom prst="rect">
-            <a:avLst/>
-          </a:prstGeom>
-          <a:noFill/>
-        </p:spPr>
-        <p:txBody>
-          <a:bodyPr wrap="square" lIns="36000" rIns="36000" tIns="18000" bIns="18000" anchor="t">
-            <a:spAutoFit/>
-          </a:bodyPr>
-          <a:lstStyle/>
-          <a:p>
-            <a:pPr algn="ctr">
-              <a:lnSpc>
-                <a:spcPct val="120000"/>
-              </a:lnSpc>
-            </a:pPr>
-            <a:r>
-              <a:rPr sz="900" b="0">
-                <a:solidFill>
-                  <a:srgbClr val="888888"/>
-                </a:solidFill>
-                <a:latin typeface="メイリオ"/>
-                <a:ea typeface="メイリオ"/>
-              </a:rPr>
-              <a:t>リッチメニュー</a:t>
-            </a:r>
-          </a:p>
-        </p:txBody>
-      </p:sp>
-      <p:sp>
-        <p:nvSpPr>
-          <p:cNvPr id="26" name="Rounded Rectangle 25"/>
+              <a:t>お問い合わせ</a:t>
+            </a:r>
+          </a:p>
+        </p:txBody>
+      </p:sp>
+      <p:sp>
+        <p:nvSpPr>
+          <p:cNvPr id="20" name="Rounded Rectangle 19"/>
           <p:cNvSpPr/>
           <p:nvPr/>
         </p:nvSpPr>
@@ -23942,7 +23690,7 @@
       </p:sp>
       <p:sp>
         <p:nvSpPr>
-          <p:cNvPr id="27" name="Rectangle 26"/>
+          <p:cNvPr id="21" name="Rectangle 20"/>
           <p:cNvSpPr/>
           <p:nvPr/>
         </p:nvSpPr>
@@ -23986,7 +23734,7 @@
       </p:sp>
       <p:sp>
         <p:nvSpPr>
-          <p:cNvPr id="28" name="TextBox 27"/>
+          <p:cNvPr id="22" name="TextBox 21"/>
           <p:cNvSpPr txBox="1"/>
           <p:nvPr/>
         </p:nvSpPr>
@@ -24026,7 +23774,7 @@
       </p:sp>
       <p:sp>
         <p:nvSpPr>
-          <p:cNvPr id="29" name="Rectangle 28"/>
+          <p:cNvPr id="23" name="Rectangle 22"/>
           <p:cNvSpPr/>
           <p:nvPr/>
         </p:nvSpPr>
@@ -24070,7 +23818,7 @@
       </p:sp>
       <p:sp>
         <p:nvSpPr>
-          <p:cNvPr id="30" name="TextBox 29"/>
+          <p:cNvPr id="24" name="TextBox 23"/>
           <p:cNvSpPr txBox="1"/>
           <p:nvPr/>
         </p:nvSpPr>
@@ -24110,7 +23858,7 @@
       </p:sp>
       <p:sp>
         <p:nvSpPr>
-          <p:cNvPr id="31" name="TextBox 30"/>
+          <p:cNvPr id="25" name="TextBox 24"/>
           <p:cNvSpPr txBox="1"/>
           <p:nvPr/>
         </p:nvSpPr>
@@ -24150,7 +23898,7 @@
       </p:sp>
       <p:sp>
         <p:nvSpPr>
-          <p:cNvPr id="32" name="TextBox 31"/>
+          <p:cNvPr id="26" name="TextBox 25"/>
           <p:cNvSpPr txBox="1"/>
           <p:nvPr/>
         </p:nvSpPr>
@@ -24190,7 +23938,7 @@
       </p:sp>
       <p:sp>
         <p:nvSpPr>
-          <p:cNvPr id="33" name="TextBox 32"/>
+          <p:cNvPr id="27" name="TextBox 26"/>
           <p:cNvSpPr txBox="1"/>
           <p:nvPr/>
         </p:nvSpPr>
@@ -24230,7 +23978,7 @@
       </p:sp>
       <p:sp>
         <p:nvSpPr>
-          <p:cNvPr id="34" name="TextBox 33"/>
+          <p:cNvPr id="28" name="TextBox 27"/>
           <p:cNvSpPr txBox="1"/>
           <p:nvPr/>
         </p:nvSpPr>
@@ -24270,7 +24018,7 @@
       </p:sp>
       <p:sp>
         <p:nvSpPr>
-          <p:cNvPr id="35" name="TextBox 34"/>
+          <p:cNvPr id="29" name="TextBox 28"/>
           <p:cNvSpPr txBox="1"/>
           <p:nvPr/>
         </p:nvSpPr>
@@ -24310,7 +24058,7 @@
       </p:sp>
       <p:sp>
         <p:nvSpPr>
-          <p:cNvPr id="36" name="TextBox 35"/>
+          <p:cNvPr id="30" name="TextBox 29"/>
           <p:cNvSpPr txBox="1"/>
           <p:nvPr/>
         </p:nvSpPr>
@@ -24350,7 +24098,7 @@
       </p:sp>
       <p:sp>
         <p:nvSpPr>
-          <p:cNvPr id="37" name="TextBox 36"/>
+          <p:cNvPr id="31" name="TextBox 30"/>
           <p:cNvSpPr txBox="1"/>
           <p:nvPr/>
         </p:nvSpPr>
@@ -24390,7 +24138,7 @@
       </p:sp>
       <p:sp>
         <p:nvSpPr>
-          <p:cNvPr id="38" name="TextBox 37"/>
+          <p:cNvPr id="32" name="TextBox 31"/>
           <p:cNvSpPr txBox="1"/>
           <p:nvPr/>
         </p:nvSpPr>
@@ -24430,7 +24178,7 @@
       </p:sp>
       <p:sp>
         <p:nvSpPr>
-          <p:cNvPr id="39" name="TextBox 38"/>
+          <p:cNvPr id="33" name="TextBox 32"/>
           <p:cNvSpPr txBox="1"/>
           <p:nvPr/>
         </p:nvSpPr>
@@ -24470,7 +24218,7 @@
       </p:sp>
       <p:sp>
         <p:nvSpPr>
-          <p:cNvPr id="40" name="TextBox 39"/>
+          <p:cNvPr id="34" name="TextBox 33"/>
           <p:cNvSpPr txBox="1"/>
           <p:nvPr/>
         </p:nvSpPr>
@@ -24510,7 +24258,7 @@
       </p:sp>
       <p:sp>
         <p:nvSpPr>
-          <p:cNvPr id="41" name="TextBox 40"/>
+          <p:cNvPr id="35" name="TextBox 34"/>
           <p:cNvSpPr txBox="1"/>
           <p:nvPr/>
         </p:nvSpPr>
@@ -24550,7 +24298,7 @@
       </p:sp>
       <p:sp>
         <p:nvSpPr>
-          <p:cNvPr id="42" name="TextBox 41"/>
+          <p:cNvPr id="36" name="TextBox 35"/>
           <p:cNvSpPr txBox="1"/>
           <p:nvPr/>
         </p:nvSpPr>
@@ -24590,7 +24338,7 @@
       </p:sp>
       <p:sp>
         <p:nvSpPr>
-          <p:cNvPr id="43" name="TextBox 42"/>
+          <p:cNvPr id="37" name="TextBox 36"/>
           <p:cNvSpPr txBox="1"/>
           <p:nvPr/>
         </p:nvSpPr>
@@ -24630,7 +24378,7 @@
       </p:sp>
       <p:sp>
         <p:nvSpPr>
-          <p:cNvPr id="44" name="TextBox 43"/>
+          <p:cNvPr id="38" name="TextBox 37"/>
           <p:cNvSpPr txBox="1"/>
           <p:nvPr/>
         </p:nvSpPr>
@@ -24670,7 +24418,7 @@
       </p:sp>
       <p:sp>
         <p:nvSpPr>
-          <p:cNvPr id="45" name="TextBox 44"/>
+          <p:cNvPr id="39" name="TextBox 38"/>
           <p:cNvSpPr txBox="1"/>
           <p:nvPr/>
         </p:nvSpPr>
@@ -24710,7 +24458,7 @@
       </p:sp>
       <p:sp>
         <p:nvSpPr>
-          <p:cNvPr id="46" name="TextBox 45"/>
+          <p:cNvPr id="40" name="TextBox 39"/>
           <p:cNvSpPr txBox="1"/>
           <p:nvPr/>
         </p:nvSpPr>
@@ -24750,7 +24498,7 @@
       </p:sp>
       <p:sp>
         <p:nvSpPr>
-          <p:cNvPr id="47" name="TextBox 46"/>
+          <p:cNvPr id="41" name="TextBox 40"/>
           <p:cNvSpPr txBox="1"/>
           <p:nvPr/>
         </p:nvSpPr>
@@ -24790,7 +24538,7 @@
       </p:sp>
       <p:sp>
         <p:nvSpPr>
-          <p:cNvPr id="48" name="TextBox 47"/>
+          <p:cNvPr id="42" name="TextBox 41"/>
           <p:cNvSpPr txBox="1"/>
           <p:nvPr/>
         </p:nvSpPr>
@@ -24830,7 +24578,7 @@
       </p:sp>
       <p:sp>
         <p:nvSpPr>
-          <p:cNvPr id="49" name="TextBox 48"/>
+          <p:cNvPr id="43" name="TextBox 42"/>
           <p:cNvSpPr txBox="1"/>
           <p:nvPr/>
         </p:nvSpPr>
@@ -24870,7 +24618,7 @@
       </p:sp>
       <p:sp>
         <p:nvSpPr>
-          <p:cNvPr id="50" name="TextBox 49"/>
+          <p:cNvPr id="44" name="TextBox 43"/>
           <p:cNvSpPr txBox="1"/>
           <p:nvPr/>
         </p:nvSpPr>
@@ -24910,7 +24658,7 @@
       </p:sp>
       <p:sp>
         <p:nvSpPr>
-          <p:cNvPr id="51" name="TextBox 50"/>
+          <p:cNvPr id="45" name="TextBox 44"/>
           <p:cNvSpPr txBox="1"/>
           <p:nvPr/>
         </p:nvSpPr>
@@ -24950,7 +24698,7 @@
       </p:sp>
       <p:sp>
         <p:nvSpPr>
-          <p:cNvPr id="52" name="TextBox 51"/>
+          <p:cNvPr id="46" name="TextBox 45"/>
           <p:cNvSpPr txBox="1"/>
           <p:nvPr/>
         </p:nvSpPr>
@@ -24990,7 +24738,7 @@
       </p:sp>
       <p:sp>
         <p:nvSpPr>
-          <p:cNvPr id="53" name="TextBox 52"/>
+          <p:cNvPr id="47" name="TextBox 46"/>
           <p:cNvSpPr txBox="1"/>
           <p:nvPr/>
         </p:nvSpPr>
@@ -25030,7 +24778,7 @@
       </p:sp>
       <p:sp>
         <p:nvSpPr>
-          <p:cNvPr id="54" name="TextBox 53"/>
+          <p:cNvPr id="48" name="TextBox 47"/>
           <p:cNvSpPr txBox="1"/>
           <p:nvPr/>
         </p:nvSpPr>
@@ -25070,7 +24818,7 @@
       </p:sp>
       <p:sp>
         <p:nvSpPr>
-          <p:cNvPr id="55" name="TextBox 54"/>
+          <p:cNvPr id="49" name="TextBox 48"/>
           <p:cNvSpPr txBox="1"/>
           <p:nvPr/>
         </p:nvSpPr>
@@ -25110,7 +24858,7 @@
       </p:sp>
       <p:sp>
         <p:nvSpPr>
-          <p:cNvPr id="56" name="TextBox 55"/>
+          <p:cNvPr id="50" name="TextBox 49"/>
           <p:cNvSpPr txBox="1"/>
           <p:nvPr/>
         </p:nvSpPr>
@@ -25150,7 +24898,7 @@
       </p:sp>
       <p:sp>
         <p:nvSpPr>
-          <p:cNvPr id="57" name="TextBox 56"/>
+          <p:cNvPr id="51" name="TextBox 50"/>
           <p:cNvSpPr txBox="1"/>
           <p:nvPr/>
         </p:nvSpPr>
@@ -25190,7 +24938,7 @@
       </p:sp>
       <p:sp>
         <p:nvSpPr>
-          <p:cNvPr id="58" name="TextBox 57"/>
+          <p:cNvPr id="52" name="TextBox 51"/>
           <p:cNvSpPr txBox="1"/>
           <p:nvPr/>
         </p:nvSpPr>
@@ -25230,7 +24978,7 @@
       </p:sp>
       <p:sp>
         <p:nvSpPr>
-          <p:cNvPr id="59" name="TextBox 58"/>
+          <p:cNvPr id="53" name="TextBox 52"/>
           <p:cNvSpPr txBox="1"/>
           <p:nvPr/>
         </p:nvSpPr>
@@ -25270,7 +25018,7 @@
       </p:sp>
       <p:sp>
         <p:nvSpPr>
-          <p:cNvPr id="60" name="TextBox 59"/>
+          <p:cNvPr id="54" name="TextBox 53"/>
           <p:cNvSpPr txBox="1"/>
           <p:nvPr/>
         </p:nvSpPr>
@@ -25310,7 +25058,7 @@
       </p:sp>
       <p:sp>
         <p:nvSpPr>
-          <p:cNvPr id="61" name="TextBox 60"/>
+          <p:cNvPr id="55" name="TextBox 54"/>
           <p:cNvSpPr txBox="1"/>
           <p:nvPr/>
         </p:nvSpPr>
@@ -25350,7 +25098,7 @@
       </p:sp>
       <p:sp>
         <p:nvSpPr>
-          <p:cNvPr id="62" name="TextBox 61"/>
+          <p:cNvPr id="56" name="TextBox 55"/>
           <p:cNvSpPr txBox="1"/>
           <p:nvPr/>
         </p:nvSpPr>
@@ -25390,7 +25138,7 @@
       </p:sp>
       <p:sp>
         <p:nvSpPr>
-          <p:cNvPr id="63" name="TextBox 62"/>
+          <p:cNvPr id="57" name="TextBox 56"/>
           <p:cNvSpPr txBox="1"/>
           <p:nvPr/>
         </p:nvSpPr>
@@ -25430,7 +25178,7 @@
       </p:sp>
       <p:sp>
         <p:nvSpPr>
-          <p:cNvPr id="64" name="TextBox 63"/>
+          <p:cNvPr id="58" name="TextBox 57"/>
           <p:cNvSpPr txBox="1"/>
           <p:nvPr/>
         </p:nvSpPr>
@@ -25470,7 +25218,7 @@
       </p:sp>
       <p:sp>
         <p:nvSpPr>
-          <p:cNvPr id="65" name="TextBox 64"/>
+          <p:cNvPr id="59" name="TextBox 58"/>
           <p:cNvSpPr txBox="1"/>
           <p:nvPr/>
         </p:nvSpPr>
@@ -25510,7 +25258,7 @@
       </p:sp>
       <p:sp>
         <p:nvSpPr>
-          <p:cNvPr id="66" name="TextBox 65"/>
+          <p:cNvPr id="60" name="TextBox 59"/>
           <p:cNvSpPr txBox="1"/>
           <p:nvPr/>
         </p:nvSpPr>
@@ -25550,7 +25298,7 @@
       </p:sp>
       <p:sp>
         <p:nvSpPr>
-          <p:cNvPr id="67" name="TextBox 66"/>
+          <p:cNvPr id="61" name="TextBox 60"/>
           <p:cNvSpPr txBox="1"/>
           <p:nvPr/>
         </p:nvSpPr>
@@ -25590,7 +25338,7 @@
       </p:sp>
       <p:sp>
         <p:nvSpPr>
-          <p:cNvPr id="68" name="TextBox 67"/>
+          <p:cNvPr id="62" name="TextBox 61"/>
           <p:cNvSpPr txBox="1"/>
           <p:nvPr/>
         </p:nvSpPr>
@@ -25630,7 +25378,7 @@
       </p:sp>
       <p:sp>
         <p:nvSpPr>
-          <p:cNvPr id="69" name="TextBox 68"/>
+          <p:cNvPr id="63" name="TextBox 62"/>
           <p:cNvSpPr txBox="1"/>
           <p:nvPr/>
         </p:nvSpPr>
@@ -25670,7 +25418,7 @@
       </p:sp>
       <p:sp>
         <p:nvSpPr>
-          <p:cNvPr id="70" name="TextBox 69"/>
+          <p:cNvPr id="64" name="TextBox 63"/>
           <p:cNvSpPr txBox="1"/>
           <p:nvPr/>
         </p:nvSpPr>
@@ -25710,7 +25458,7 @@
       </p:sp>
       <p:sp>
         <p:nvSpPr>
-          <p:cNvPr id="71" name="TextBox 70"/>
+          <p:cNvPr id="65" name="TextBox 64"/>
           <p:cNvSpPr txBox="1"/>
           <p:nvPr/>
         </p:nvSpPr>
@@ -25750,7 +25498,7 @@
       </p:sp>
       <p:sp>
         <p:nvSpPr>
-          <p:cNvPr id="72" name="TextBox 71"/>
+          <p:cNvPr id="66" name="TextBox 65"/>
           <p:cNvSpPr txBox="1"/>
           <p:nvPr/>
         </p:nvSpPr>
@@ -25790,7 +25538,7 @@
       </p:sp>
       <p:sp>
         <p:nvSpPr>
-          <p:cNvPr id="73" name="TextBox 72"/>
+          <p:cNvPr id="67" name="TextBox 66"/>
           <p:cNvSpPr txBox="1"/>
           <p:nvPr/>
         </p:nvSpPr>
@@ -25830,7 +25578,7 @@
       </p:sp>
       <p:sp>
         <p:nvSpPr>
-          <p:cNvPr id="74" name="TextBox 73"/>
+          <p:cNvPr id="68" name="TextBox 67"/>
           <p:cNvSpPr txBox="1"/>
           <p:nvPr/>
         </p:nvSpPr>
@@ -25870,7 +25618,7 @@
       </p:sp>
       <p:sp>
         <p:nvSpPr>
-          <p:cNvPr id="75" name="TextBox 74"/>
+          <p:cNvPr id="69" name="TextBox 68"/>
           <p:cNvSpPr txBox="1"/>
           <p:nvPr/>
         </p:nvSpPr>
@@ -25910,7 +25658,7 @@
       </p:sp>
       <p:sp>
         <p:nvSpPr>
-          <p:cNvPr id="76" name="TextBox 75"/>
+          <p:cNvPr id="70" name="TextBox 69"/>
           <p:cNvSpPr txBox="1"/>
           <p:nvPr/>
         </p:nvSpPr>
@@ -25950,7 +25698,7 @@
       </p:sp>
       <p:sp>
         <p:nvSpPr>
-          <p:cNvPr id="77" name="TextBox 76"/>
+          <p:cNvPr id="71" name="TextBox 70"/>
           <p:cNvSpPr txBox="1"/>
           <p:nvPr/>
         </p:nvSpPr>
@@ -25990,7 +25738,7 @@
       </p:sp>
       <p:sp>
         <p:nvSpPr>
-          <p:cNvPr id="78" name="TextBox 77"/>
+          <p:cNvPr id="72" name="TextBox 71"/>
           <p:cNvSpPr txBox="1"/>
           <p:nvPr/>
         </p:nvSpPr>
@@ -26030,7 +25778,7 @@
       </p:sp>
       <p:sp>
         <p:nvSpPr>
-          <p:cNvPr id="79" name="TextBox 78"/>
+          <p:cNvPr id="73" name="TextBox 72"/>
           <p:cNvSpPr txBox="1"/>
           <p:nvPr/>
         </p:nvSpPr>
@@ -26070,7 +25818,7 @@
       </p:sp>
       <p:sp>
         <p:nvSpPr>
-          <p:cNvPr id="80" name="Rounded Rectangle 79"/>
+          <p:cNvPr id="74" name="Rounded Rectangle 73"/>
           <p:cNvSpPr/>
           <p:nvPr/>
         </p:nvSpPr>
@@ -26116,7 +25864,7 @@
       </p:sp>
       <p:sp>
         <p:nvSpPr>
-          <p:cNvPr id="81" name="Rectangle 80"/>
+          <p:cNvPr id="75" name="Rectangle 74"/>
           <p:cNvSpPr/>
           <p:nvPr/>
         </p:nvSpPr>
@@ -26160,7 +25908,7 @@
       </p:sp>
       <p:sp>
         <p:nvSpPr>
-          <p:cNvPr id="82" name="TextBox 81"/>
+          <p:cNvPr id="76" name="TextBox 75"/>
           <p:cNvSpPr txBox="1"/>
           <p:nvPr/>
         </p:nvSpPr>
@@ -26200,7 +25948,7 @@
       </p:sp>
       <p:sp>
         <p:nvSpPr>
-          <p:cNvPr id="83" name="Rectangle 82"/>
+          <p:cNvPr id="77" name="Rectangle 76"/>
           <p:cNvSpPr/>
           <p:nvPr/>
         </p:nvSpPr>
@@ -26244,7 +25992,7 @@
       </p:sp>
       <p:sp>
         <p:nvSpPr>
-          <p:cNvPr id="84" name="TextBox 83"/>
+          <p:cNvPr id="78" name="TextBox 77"/>
           <p:cNvSpPr txBox="1"/>
           <p:nvPr/>
         </p:nvSpPr>
@@ -26284,7 +26032,7 @@
       </p:sp>
       <p:sp>
         <p:nvSpPr>
-          <p:cNvPr id="85" name="Rounded Rectangle 84"/>
+          <p:cNvPr id="79" name="Rounded Rectangle 78"/>
           <p:cNvSpPr/>
           <p:nvPr/>
         </p:nvSpPr>
@@ -26330,7 +26078,7 @@
       </p:sp>
       <p:sp>
         <p:nvSpPr>
-          <p:cNvPr id="86" name="TextBox 85"/>
+          <p:cNvPr id="80" name="TextBox 79"/>
           <p:cNvSpPr txBox="1"/>
           <p:nvPr/>
         </p:nvSpPr>
@@ -26370,7 +26118,7 @@
       </p:sp>
       <p:sp>
         <p:nvSpPr>
-          <p:cNvPr id="87" name="Rounded Rectangle 86"/>
+          <p:cNvPr id="81" name="Rounded Rectangle 80"/>
           <p:cNvSpPr/>
           <p:nvPr/>
         </p:nvSpPr>
@@ -26416,7 +26164,7 @@
       </p:sp>
       <p:sp>
         <p:nvSpPr>
-          <p:cNvPr id="88" name="TextBox 87"/>
+          <p:cNvPr id="82" name="TextBox 81"/>
           <p:cNvSpPr txBox="1"/>
           <p:nvPr/>
         </p:nvSpPr>
@@ -26456,7 +26204,7 @@
       </p:sp>
       <p:sp>
         <p:nvSpPr>
-          <p:cNvPr id="89" name="Rounded Rectangle 88"/>
+          <p:cNvPr id="83" name="Rounded Rectangle 82"/>
           <p:cNvSpPr/>
           <p:nvPr/>
         </p:nvSpPr>
@@ -26502,7 +26250,7 @@
       </p:sp>
       <p:sp>
         <p:nvSpPr>
-          <p:cNvPr id="90" name="TextBox 89"/>
+          <p:cNvPr id="84" name="TextBox 83"/>
           <p:cNvSpPr txBox="1"/>
           <p:nvPr/>
         </p:nvSpPr>
@@ -26542,7 +26290,7 @@
       </p:sp>
       <p:sp>
         <p:nvSpPr>
-          <p:cNvPr id="91" name="Rounded Rectangle 90"/>
+          <p:cNvPr id="85" name="Rounded Rectangle 84"/>
           <p:cNvSpPr/>
           <p:nvPr/>
         </p:nvSpPr>
@@ -26588,7 +26336,7 @@
       </p:sp>
       <p:sp>
         <p:nvSpPr>
-          <p:cNvPr id="92" name="TextBox 91"/>
+          <p:cNvPr id="86" name="TextBox 85"/>
           <p:cNvSpPr txBox="1"/>
           <p:nvPr/>
         </p:nvSpPr>
@@ -26628,7 +26376,7 @@
       </p:sp>
       <p:sp>
         <p:nvSpPr>
-          <p:cNvPr id="93" name="Rounded Rectangle 92"/>
+          <p:cNvPr id="87" name="Rounded Rectangle 86"/>
           <p:cNvSpPr/>
           <p:nvPr/>
         </p:nvSpPr>
@@ -26674,7 +26422,7 @@
       </p:sp>
       <p:sp>
         <p:nvSpPr>
-          <p:cNvPr id="94" name="TextBox 93"/>
+          <p:cNvPr id="88" name="TextBox 87"/>
           <p:cNvSpPr txBox="1"/>
           <p:nvPr/>
         </p:nvSpPr>
@@ -26714,7 +26462,7 @@
       </p:sp>
       <p:sp>
         <p:nvSpPr>
-          <p:cNvPr id="95" name="Rounded Rectangle 94"/>
+          <p:cNvPr id="89" name="Rounded Rectangle 88"/>
           <p:cNvSpPr/>
           <p:nvPr/>
         </p:nvSpPr>
@@ -26760,7 +26508,7 @@
       </p:sp>
       <p:sp>
         <p:nvSpPr>
-          <p:cNvPr id="96" name="TextBox 95"/>
+          <p:cNvPr id="90" name="TextBox 89"/>
           <p:cNvSpPr txBox="1"/>
           <p:nvPr/>
         </p:nvSpPr>
@@ -26800,7 +26548,7 @@
       </p:sp>
       <p:sp>
         <p:nvSpPr>
-          <p:cNvPr id="97" name="Right Arrow 96"/>
+          <p:cNvPr id="91" name="Right Arrow 90"/>
           <p:cNvSpPr/>
           <p:nvPr/>
         </p:nvSpPr>
@@ -26843,7 +26591,7 @@
       </p:sp>
       <p:sp>
         <p:nvSpPr>
-          <p:cNvPr id="98" name="Right Arrow 97"/>
+          <p:cNvPr id="92" name="Right Arrow 91"/>
           <p:cNvSpPr/>
           <p:nvPr/>
         </p:nvSpPr>
@@ -26886,7 +26634,7 @@
       </p:sp>
       <p:sp>
         <p:nvSpPr>
-          <p:cNvPr id="99" name="Rounded Rectangle 98"/>
+          <p:cNvPr id="93" name="Rounded Rectangle 92"/>
           <p:cNvSpPr/>
           <p:nvPr/>
         </p:nvSpPr>
@@ -26930,7 +26678,7 @@
       </p:sp>
       <p:sp>
         <p:nvSpPr>
-          <p:cNvPr id="100" name="TextBox 99"/>
+          <p:cNvPr id="94" name="TextBox 93"/>
           <p:cNvSpPr txBox="1"/>
           <p:nvPr/>
         </p:nvSpPr>
@@ -26970,7 +26718,7 @@
       </p:sp>
       <p:sp>
         <p:nvSpPr>
-          <p:cNvPr id="101" name="TextBox 100"/>
+          <p:cNvPr id="95" name="TextBox 94"/>
           <p:cNvSpPr txBox="1"/>
           <p:nvPr/>
         </p:nvSpPr>
@@ -27010,7 +26758,7 @@
       </p:sp>
       <p:sp>
         <p:nvSpPr>
-          <p:cNvPr id="102" name="TextBox 101"/>
+          <p:cNvPr id="96" name="TextBox 95"/>
           <p:cNvSpPr txBox="1"/>
           <p:nvPr/>
         </p:nvSpPr>
@@ -28970,7 +28718,7 @@
                 <a:latin typeface="メイリオ"/>
                 <a:ea typeface="メイリオ"/>
               </a:rPr>
-              <a:t>今月の売上</a:t>
+              <a:t>本日の売上</a:t>
             </a:r>
           </a:p>
         </p:txBody>
@@ -29010,7 +28758,7 @@
                 <a:latin typeface="メイリオ"/>
                 <a:ea typeface="メイリオ"/>
               </a:rPr>
-              <a:t>¥482,000</a:t>
+              <a:t>¥38,500</a:t>
             </a:r>
           </a:p>
         </p:txBody>
@@ -29096,7 +28844,7 @@
                 <a:latin typeface="メイリオ"/>
                 <a:ea typeface="メイリオ"/>
               </a:rPr>
-              <a:t>登録顧客数</a:t>
+              <a:t>今月の売上</a:t>
             </a:r>
           </a:p>
         </p:txBody>
@@ -29136,7 +28884,7 @@
                 <a:latin typeface="メイリオ"/>
                 <a:ea typeface="メイリオ"/>
               </a:rPr>
-              <a:t>128名</a:t>
+              <a:t>¥482,000</a:t>
             </a:r>
           </a:p>
         </p:txBody>
@@ -29222,7 +28970,7 @@
                 <a:latin typeface="メイリオ"/>
                 <a:ea typeface="メイリオ"/>
               </a:rPr>
-              <a:t>要注意顧客</a:t>
+              <a:t>コース残少</a:t>
             </a:r>
           </a:p>
         </p:txBody>
@@ -29998,7 +29746,7 @@
                 <a:latin typeface="メイリオ"/>
                 <a:ea typeface="メイリオ"/>
               </a:rPr>
-              <a:t>2026/04/19 05:00</a:t>
+              <a:t>2026/04/19 02:00</a:t>
             </a:r>
           </a:p>
           <a:p>
@@ -30015,7 +29763,7 @@
                 <a:latin typeface="メイリオ"/>
                 <a:ea typeface="メイリオ"/>
               </a:rPr>
-              <a:t>（週次 毎週日曜5時）</a:t>
+              <a:t>（毎週日曜 午前2時に自動実行）</a:t>
             </a:r>
           </a:p>
         </p:txBody>
@@ -30039,7 +29787,7 @@
           </a:solidFill>
           <a:ln w="19050">
             <a:solidFill>
-              <a:srgbClr val="D4A574"/>
+              <a:srgbClr val="F0A040"/>
             </a:solidFill>
           </a:ln>
           <a:effectLst/>
@@ -30096,12 +29844,12 @@
             <a:r>
               <a:rPr sz="1100" b="1">
                 <a:solidFill>
-                  <a:srgbClr val="7B4A5C"/>
-                </a:solidFill>
-                <a:latin typeface="メイリオ"/>
-                <a:ea typeface="メイリオ"/>
-              </a:rPr>
-              <a:t>📊 売上サマリー</a:t>
+                  <a:srgbClr val="F0A040"/>
+                </a:solidFill>
+                <a:latin typeface="メイリオ"/>
+                <a:ea typeface="メイリオ"/>
+              </a:rPr>
+              <a:t>⚠ コース残回数アラート</a:t>
             </a:r>
           </a:p>
         </p:txBody>
@@ -30141,7 +29889,7 @@
                 <a:latin typeface="メイリオ"/>
                 <a:ea typeface="メイリオ"/>
               </a:rPr>
-              <a:t>今週: ¥128,500</a:t>
+              <a:t>残り4回以下: 3名</a:t>
             </a:r>
           </a:p>
           <a:p>
@@ -30158,24 +29906,7 @@
                 <a:latin typeface="メイリオ"/>
                 <a:ea typeface="メイリオ"/>
               </a:rPr>
-              <a:t>今月: ¥482,000</a:t>
-            </a:r>
-          </a:p>
-          <a:p>
-            <a:pPr algn="l">
-              <a:lnSpc>
-                <a:spcPct val="130000"/>
-              </a:lnSpc>
-            </a:pPr>
-            <a:r>
-              <a:rPr sz="1000" b="0">
-                <a:solidFill>
-                  <a:srgbClr val="333333"/>
-                </a:solidFill>
-                <a:latin typeface="メイリオ"/>
-                <a:ea typeface="メイリオ"/>
-              </a:rPr>
-              <a:t>前月比: +12%</a:t>
+              <a:t>→ 次回来店時にご案内を</a:t>
             </a:r>
           </a:p>
         </p:txBody>
@@ -33838,14 +33569,14 @@
               </a:lnSpc>
             </a:pPr>
             <a:r>
-              <a:rPr sz="1500" b="0">
+              <a:rPr sz="1400" b="0">
                 <a:solidFill>
                   <a:srgbClr val="7B4A5C"/>
                 </a:solidFill>
                 <a:latin typeface="メイリオ"/>
                 <a:ea typeface="メイリオ"/>
               </a:rPr>
-              <a:t>月別・日別の売上が、グラフで一目瞭然。CSVでダウンロードも可能。</a:t>
+              <a:t>月別・日別の売上が、グラフで一目瞭然。売上明細・顧客一覧・予約台帳はCSVでダウンロードできます（Excel対応）。</a:t>
             </a:r>
           </a:p>
         </p:txBody>
@@ -35098,14 +34829,14 @@
               </a:lnSpc>
             </a:pPr>
             <a:r>
-              <a:rPr sz="1300" b="1">
+              <a:rPr sz="1200" b="1">
                 <a:solidFill>
                   <a:srgbClr val="7B4A5C"/>
                 </a:solidFill>
                 <a:latin typeface="メイリオ"/>
                 <a:ea typeface="メイリオ"/>
               </a:rPr>
-              <a:t>📁 支払い履歴ダウンロード</a:t>
+              <a:t>📁 CSVダウンロード（売上／顧客／予約）</a:t>
             </a:r>
           </a:p>
         </p:txBody>

</xml_diff>